<commit_message>
Refine strategic deck copy for executive tone
Co-authored-by: EmberEnterprises <EmberEnterprises@users.noreply.github.com>
</commit_message>
<xml_diff>
--- a/public/Stillform_Strategic_Overview.pptx
+++ b/public/Stillform_Strategic_Overview.pptx
@@ -3285,7 +3285,7 @@
                 </a:solidFill>
                 <a:latin typeface="DM Sans"/>
               </a:rPr>
-              <a:t>Preventive risk management for human behavior · science-first operating deck</a:t>
+              <a:t>Preventive risk management for human behavior</a:t>
             </a:r>
           </a:p>
         </p:txBody>
@@ -3685,7 +3685,7 @@
                 </a:solidFill>
                 <a:latin typeface="DM Sans"/>
               </a:rPr>
-              <a:t>Operator-grade economics and channel logic.</a:t>
+              <a:t>Focused economics and trust-first channel strategy.</a:t>
             </a:r>
           </a:p>
         </p:txBody>
@@ -4180,7 +4180,7 @@
                           </a:solidFill>
                           <a:latin typeface="DM Sans"/>
                         </a:rPr>
-                        <a:t>Trust transfer beats cold paid acquisition</a:t>
+                        <a:t>Trust transfer outperforms cold paid acquisition</a:t>
                       </a:r>
                     </a:p>
                   </a:txBody>
@@ -5363,7 +5363,7 @@
                 </a:solidFill>
                 <a:latin typeface="DM Sans"/>
               </a:rPr>
-              <a:t>Release discipline and risk controls as product features.</a:t>
+              <a:t>Release discipline is part of the product, not an afterthought.</a:t>
             </a:r>
           </a:p>
         </p:txBody>
@@ -6437,7 +6437,7 @@
                 </a:solidFill>
                 <a:latin typeface="DM Sans"/>
               </a:rPr>
-              <a:t>Who / What / How / Why with zero category drift.</a:t>
+              <a:t>Clear category definition and operating thesis.</a:t>
             </a:r>
           </a:p>
         </p:txBody>
@@ -6643,7 +6643,7 @@
                 </a:solidFill>
                 <a:latin typeface="DM Sans"/>
               </a:rPr>
-              <a:t>Core framing constraints</a:t>
+              <a:t>Category, mechanism, and strategic position</a:t>
             </a:r>
           </a:p>
         </p:txBody>
@@ -6932,7 +6932,7 @@
                           </a:solidFill>
                           <a:latin typeface="DM Sans"/>
                         </a:rPr>
-                        <a:t>Mechanism-driven architecture, not inspirational content.</a:t>
+                        <a:t>Mechanism-driven architecture, not inspiration content.</a:t>
                       </a:r>
                     </a:p>
                   </a:txBody>
@@ -7339,7 +7339,7 @@
                 </a:solidFill>
                 <a:latin typeface="DM Sans"/>
               </a:rPr>
-              <a:t>Mechanism table split into clean slides for readability.</a:t>
+              <a:t>Science is operationalized as product behavior, not decoration.</a:t>
             </a:r>
           </a:p>
         </p:txBody>

</xml_diff>

<commit_message>
Rebuild deck around Stillform applied science domains
Co-authored-by: EmberEnterprises <EmberEnterprises@users.noreply.github.com>
</commit_message>
<xml_diff>
--- a/public/Stillform_Strategic_Overview.pptx
+++ b/public/Stillform_Strategic_Overview.pptx
@@ -132,18 +132,18 @@
               <c:strCache>
                 <c:ptCount val="1"/>
                 <c:pt idx="0">
-                  <c:v>Global adults (%)</c:v>
+                  <c:v>Negative emotions (%)</c:v>
                 </c:pt>
               </c:strCache>
             </c:strRef>
           </c:tx>
           <c:spPr>
             <a:solidFill>
-              <a:srgbClr val="EBAB4A"/>
+              <a:srgbClr val="D76060"/>
             </a:solidFill>
             <a:ln>
               <a:solidFill>
-                <a:srgbClr val="EBAB4A"/>
+                <a:srgbClr val="D76060"/>
               </a:solidFill>
             </a:ln>
           </c:spPr>
@@ -285,6 +285,176 @@
 </file>
 
 <file path=ppt/charts/chart2.xml><?xml version="1.0" encoding="utf-8"?>
+<c:chartSpace xmlns:c="http://schemas.openxmlformats.org/drawingml/2006/chart" xmlns:a="http://schemas.openxmlformats.org/drawingml/2006/main" xmlns:r="http://schemas.openxmlformats.org/officeDocument/2006/relationships">
+  <c:date1904 val="0"/>
+  <c:chart>
+    <c:autoTitleDeleted val="0"/>
+    <c:plotArea>
+      <c:barChart>
+        <c:barDir val="bar"/>
+        <c:grouping val="clustered"/>
+        <c:ser>
+          <c:idx val="0"/>
+          <c:order val="0"/>
+          <c:tx>
+            <c:strRef>
+              <c:f>Sheet1!$B$1</c:f>
+              <c:strCache>
+                <c:ptCount val="1"/>
+                <c:pt idx="0">
+                  <c:v>Positive experiences (%)</c:v>
+                </c:pt>
+              </c:strCache>
+            </c:strRef>
+          </c:tx>
+          <c:spPr>
+            <a:solidFill>
+              <a:srgbClr val="63BF93"/>
+            </a:solidFill>
+            <a:ln>
+              <a:solidFill>
+                <a:srgbClr val="63BF93"/>
+              </a:solidFill>
+            </a:ln>
+          </c:spPr>
+          <c:cat>
+            <c:strRef>
+              <c:f>Sheet1!$A$2:$A$6</c:f>
+              <c:strCache>
+                <c:ptCount val="5"/>
+                <c:pt idx="0">
+                  <c:v>Respect</c:v>
+                </c:pt>
+                <c:pt idx="1">
+                  <c:v>Laughter</c:v>
+                </c:pt>
+                <c:pt idx="2">
+                  <c:v>Enjoyment</c:v>
+                </c:pt>
+                <c:pt idx="3">
+                  <c:v>Well-rested</c:v>
+                </c:pt>
+                <c:pt idx="4">
+                  <c:v>Learned</c:v>
+                </c:pt>
+              </c:strCache>
+            </c:strRef>
+          </c:cat>
+          <c:val>
+            <c:numRef>
+              <c:f>Sheet1!$B$2:$B$6</c:f>
+              <c:numCache>
+                <c:formatCode>General</c:formatCode>
+                <c:ptCount val="5"/>
+                <c:pt idx="0">
+                  <c:v>88</c:v>
+                </c:pt>
+                <c:pt idx="1">
+                  <c:v>73</c:v>
+                </c:pt>
+                <c:pt idx="2">
+                  <c:v>73</c:v>
+                </c:pt>
+                <c:pt idx="3">
+                  <c:v>72</c:v>
+                </c:pt>
+                <c:pt idx="4">
+                  <c:v>52</c:v>
+                </c:pt>
+              </c:numCache>
+            </c:numRef>
+          </c:val>
+        </c:ser>
+        <c:axId val="-2068027336"/>
+        <c:axId val="-2113994440"/>
+      </c:barChart>
+      <c:catAx>
+        <c:axId val="-2068027336"/>
+        <c:scaling>
+          <c:orientation val="minMax"/>
+        </c:scaling>
+        <c:delete val="0"/>
+        <c:axPos val="l"/>
+        <c:majorTickMark val="out"/>
+        <c:minorTickMark val="none"/>
+        <c:tickLblPos val="nextTo"/>
+        <c:txPr>
+          <a:bodyPr/>
+          <a:lstStyle/>
+          <a:p>
+            <a:pPr>
+              <a:defRPr sz="1100">
+                <a:solidFill>
+                  <a:srgbClr val="A6B0BF"/>
+                </a:solidFill>
+                <a:latin typeface="Calibri"/>
+              </a:defRPr>
+            </a:pPr>
+          </a:p>
+        </c:txPr>
+        <c:crossAx val="-2113994440"/>
+        <c:crosses val="autoZero"/>
+        <c:auto val="1"/>
+        <c:lblAlgn val="ctr"/>
+        <c:lblOffset val="100"/>
+        <c:noMultiLvlLbl val="0"/>
+      </c:catAx>
+      <c:valAx>
+        <c:axId val="-2113994440"/>
+        <c:scaling>
+          <c:max val="100.0"/>
+        </c:scaling>
+        <c:delete val="0"/>
+        <c:axPos val="b"/>
+        <c:majorGridlines>
+          <c:spPr>
+            <a:ln>
+              <a:solidFill>
+                <a:srgbClr val="363F4F"/>
+              </a:solidFill>
+            </a:ln>
+          </c:spPr>
+        </c:majorGridlines>
+        <c:majorTickMark val="out"/>
+        <c:minorTickMark val="none"/>
+        <c:tickLblPos val="nextTo"/>
+        <c:txPr>
+          <a:bodyPr/>
+          <a:lstStyle/>
+          <a:p>
+            <a:pPr>
+              <a:defRPr sz="1100">
+                <a:solidFill>
+                  <a:srgbClr val="A6B0BF"/>
+                </a:solidFill>
+                <a:latin typeface="Calibri"/>
+              </a:defRPr>
+            </a:pPr>
+          </a:p>
+        </c:txPr>
+        <c:crossAx val="-2068027336"/>
+        <c:crosses val="autoZero"/>
+      </c:valAx>
+    </c:plotArea>
+    <c:dispBlanksAs val="gap"/>
+  </c:chart>
+  <c:txPr>
+    <a:bodyPr/>
+    <a:lstStyle/>
+    <a:p>
+      <a:pPr>
+        <a:defRPr sz="1800"/>
+      </a:pPr>
+      <a:endParaRPr lang="en-US"/>
+    </a:p>
+  </c:txPr>
+  <c:externalData r:id="rId1">
+    <c:autoUpdate val="0"/>
+  </c:externalData>
+</c:chartSpace>
+</file>
+
+<file path=ppt/charts/chart3.xml><?xml version="1.0" encoding="utf-8"?>
 <c:chartSpace xmlns:c="http://schemas.openxmlformats.org/drawingml/2006/chart" xmlns:a="http://schemas.openxmlformats.org/drawingml/2006/main" xmlns:r="http://schemas.openxmlformats.org/officeDocument/2006/relationships">
   <c:date1904 val="0"/>
   <c:chart>
@@ -446,7 +616,7 @@
 </c:chartSpace>
 </file>
 
-<file path=ppt/charts/chart3.xml><?xml version="1.0" encoding="utf-8"?>
+<file path=ppt/charts/chart4.xml><?xml version="1.0" encoding="utf-8"?>
 <c:chartSpace xmlns:c="http://schemas.openxmlformats.org/drawingml/2006/chart" xmlns:a="http://schemas.openxmlformats.org/drawingml/2006/main" xmlns:r="http://schemas.openxmlformats.org/officeDocument/2006/relationships">
   <c:date1904 val="0"/>
   <c:chart>
@@ -702,7 +872,7 @@
 </c:chartSpace>
 </file>
 
-<file path=ppt/charts/chart4.xml><?xml version="1.0" encoding="utf-8"?>
+<file path=ppt/charts/chart5.xml><?xml version="1.0" encoding="utf-8"?>
 <c:chartSpace xmlns:c="http://schemas.openxmlformats.org/drawingml/2006/chart" xmlns:a="http://schemas.openxmlformats.org/drawingml/2006/main" xmlns:r="http://schemas.openxmlformats.org/officeDocument/2006/relationships">
   <c:date1904 val="0"/>
   <c:chart>
@@ -927,7 +1097,7 @@
 </c:chartSpace>
 </file>
 
-<file path=ppt/charts/chart5.xml><?xml version="1.0" encoding="utf-8"?>
+<file path=ppt/charts/chart6.xml><?xml version="1.0" encoding="utf-8"?>
 <c:chartSpace xmlns:c="http://schemas.openxmlformats.org/drawingml/2006/chart" xmlns:a="http://schemas.openxmlformats.org/drawingml/2006/main" xmlns:r="http://schemas.openxmlformats.org/officeDocument/2006/relationships">
   <c:date1904 val="0"/>
   <c:chart>
@@ -4601,7 +4771,7 @@
                 </a:solidFill>
                 <a:latin typeface="Calibri"/>
               </a:rPr>
-              <a:t>Global Emotional Load</a:t>
+              <a:t>Global Emotional Landscape</a:t>
             </a:r>
           </a:p>
         </p:txBody>
@@ -4635,7 +4805,7 @@
                 </a:solidFill>
                 <a:latin typeface="Calibri"/>
               </a:rPr>
-              <a:t>Daily distress indicators remain elevated worldwide</a:t>
+              <a:t>Risk signals and capacity signals both matter</a:t>
             </a:r>
           </a:p>
         </p:txBody>
@@ -4649,7 +4819,7 @@
         <p:spPr>
           <a:xfrm>
             <a:off x="685800" y="1901952"/>
-            <a:ext cx="7360920" cy="4251960"/>
+            <a:ext cx="5486400" cy="4251960"/>
           </a:xfrm>
           <a:prstGeom prst="roundRect">
             <a:avLst/>
@@ -4694,8 +4864,8 @@
           <p:nvPr/>
         </p:nvGraphicFramePr>
         <p:xfrm>
-          <a:off x="960120" y="2240280"/>
-          <a:ext cx="6812280" cy="3611880"/>
+          <a:off x="914400" y="2331720"/>
+          <a:ext cx="5074920" cy="3520440"/>
         </p:xfrm>
         <a:graphic>
           <a:graphicData uri="http://schemas.openxmlformats.org/drawingml/2006/chart">
@@ -4711,8 +4881,8 @@
         </p:nvSpPr>
         <p:spPr>
           <a:xfrm>
-            <a:off x="8275320" y="1901952"/>
-            <a:ext cx="3246120" cy="4251960"/>
+            <a:off x="6355080" y="1901952"/>
+            <a:ext cx="5349240" cy="4251960"/>
           </a:xfrm>
           <a:prstGeom prst="roundRect">
             <a:avLst/>
@@ -4748,16 +4918,34 @@
           </a:p>
         </p:txBody>
       </p:sp>
-      <p:sp>
-        <p:nvSpPr>
-          <p:cNvPr id="10" name="TextBox 9"/>
+      <p:graphicFrame>
+        <p:nvGraphicFramePr>
+          <p:cNvPr id="10" name="Chart 9"/>
+          <p:cNvGraphicFramePr>
+            <a:graphicFrameLocks noGrp="1"/>
+          </p:cNvGraphicFramePr>
+          <p:nvPr/>
+        </p:nvGraphicFramePr>
+        <p:xfrm>
+          <a:off x="6583680" y="2331720"/>
+          <a:ext cx="4937760" cy="3520440"/>
+        </p:xfrm>
+        <a:graphic>
+          <a:graphicData uri="http://schemas.openxmlformats.org/drawingml/2006/chart">
+            <c:chart xmlns:c="http://schemas.openxmlformats.org/drawingml/2006/chart" r:id="rId3"/>
+          </a:graphicData>
+        </a:graphic>
+      </p:graphicFrame>
+      <p:sp>
+        <p:nvSpPr>
+          <p:cNvPr id="11" name="TextBox 10"/>
           <p:cNvSpPr txBox="1"/>
           <p:nvPr/>
         </p:nvSpPr>
         <p:spPr>
           <a:xfrm>
-            <a:off x="8549640" y="2240280"/>
-            <a:ext cx="2560320" cy="1463040"/>
+            <a:off x="685800" y="6464808"/>
+            <a:ext cx="10972800" cy="219456"/>
           </a:xfrm>
           <a:prstGeom prst="rect">
             <a:avLst/>
@@ -4770,155 +4958,14 @@
           </a:bodyPr>
           <a:lstStyle/>
           <a:p>
-            <a:pPr algn="l"/>
-            <a:r>
-              <a:rPr sz="1000">
+            <a:r>
+              <a:rPr sz="900">
                 <a:solidFill>
                   <a:srgbClr val="A6B0BF"/>
                 </a:solidFill>
                 <a:latin typeface="Consolas"/>
               </a:rPr>
-              <a:t>WORRY</a:t>
-            </a:r>
-          </a:p>
-          <a:p>
-            <a:pPr algn="l"/>
-            <a:r>
-              <a:rPr sz="3800" b="1">
-                <a:solidFill>
-                  <a:srgbClr val="D76060"/>
-                </a:solidFill>
-                <a:latin typeface="Calibri"/>
-              </a:rPr>
-              <a:t>39%</a:t>
-            </a:r>
-          </a:p>
-        </p:txBody>
-      </p:sp>
-      <p:sp>
-        <p:nvSpPr>
-          <p:cNvPr id="11" name="TextBox 10"/>
-          <p:cNvSpPr txBox="1"/>
-          <p:nvPr/>
-        </p:nvSpPr>
-        <p:spPr>
-          <a:xfrm>
-            <a:off x="8549640" y="3401568"/>
-            <a:ext cx="2560320" cy="1463040"/>
-          </a:xfrm>
-          <a:prstGeom prst="rect">
-            <a:avLst/>
-          </a:prstGeom>
-          <a:noFill/>
-        </p:spPr>
-        <p:txBody>
-          <a:bodyPr wrap="none">
-            <a:spAutoFit/>
-          </a:bodyPr>
-          <a:lstStyle/>
-          <a:p>
-            <a:pPr algn="l"/>
-            <a:r>
-              <a:rPr sz="1000">
-                <a:solidFill>
-                  <a:srgbClr val="A6B0BF"/>
-                </a:solidFill>
-                <a:latin typeface="Consolas"/>
-              </a:rPr>
-              <a:t>STRESS</a:t>
-            </a:r>
-          </a:p>
-          <a:p>
-            <a:pPr algn="l"/>
-            <a:r>
-              <a:rPr sz="3800" b="1">
-                <a:solidFill>
-                  <a:srgbClr val="EBAB4A"/>
-                </a:solidFill>
-                <a:latin typeface="Calibri"/>
-              </a:rPr>
-              <a:t>37%</a:t>
-            </a:r>
-          </a:p>
-        </p:txBody>
-      </p:sp>
-      <p:sp>
-        <p:nvSpPr>
-          <p:cNvPr id="12" name="TextBox 11"/>
-          <p:cNvSpPr txBox="1"/>
-          <p:nvPr/>
-        </p:nvSpPr>
-        <p:spPr>
-          <a:xfrm>
-            <a:off x="8549640" y="4562856"/>
-            <a:ext cx="2560320" cy="1463040"/>
-          </a:xfrm>
-          <a:prstGeom prst="rect">
-            <a:avLst/>
-          </a:prstGeom>
-          <a:noFill/>
-        </p:spPr>
-        <p:txBody>
-          <a:bodyPr wrap="none">
-            <a:spAutoFit/>
-          </a:bodyPr>
-          <a:lstStyle/>
-          <a:p>
-            <a:pPr algn="l"/>
-            <a:r>
-              <a:rPr sz="1000">
-                <a:solidFill>
-                  <a:srgbClr val="A6B0BF"/>
-                </a:solidFill>
-                <a:latin typeface="Consolas"/>
-              </a:rPr>
-              <a:t>PAIN</a:t>
-            </a:r>
-          </a:p>
-          <a:p>
-            <a:pPr algn="l"/>
-            <a:r>
-              <a:rPr sz="3800" b="1">
-                <a:solidFill>
-                  <a:srgbClr val="5E99F4"/>
-                </a:solidFill>
-                <a:latin typeface="Calibri"/>
-              </a:rPr>
-              <a:t>32%</a:t>
-            </a:r>
-          </a:p>
-        </p:txBody>
-      </p:sp>
-      <p:sp>
-        <p:nvSpPr>
-          <p:cNvPr id="13" name="TextBox 12"/>
-          <p:cNvSpPr txBox="1"/>
-          <p:nvPr/>
-        </p:nvSpPr>
-        <p:spPr>
-          <a:xfrm>
-            <a:off x="685800" y="6464808"/>
-            <a:ext cx="10972800" cy="219456"/>
-          </a:xfrm>
-          <a:prstGeom prst="rect">
-            <a:avLst/>
-          </a:prstGeom>
-          <a:noFill/>
-        </p:spPr>
-        <p:txBody>
-          <a:bodyPr wrap="none">
-            <a:spAutoFit/>
-          </a:bodyPr>
-          <a:lstStyle/>
-          <a:p>
-            <a:r>
-              <a:rPr sz="900">
-                <a:solidFill>
-                  <a:srgbClr val="A6B0BF"/>
-                </a:solidFill>
-                <a:latin typeface="Consolas"/>
-              </a:rPr>
-              <a:t>Source: Gallup State of the World's Emotional Health (2024 global survey)</a:t>
+              <a:t>Source: Gallup State of the World's Emotional Health (2024 global survey): negative + positive indicators</a:t>
             </a:r>
           </a:p>
         </p:txBody>

</xml_diff>